<commit_message>
Update repo link in Phase 2 deck
</commit_message>
<xml_diff>
--- a/docs/Phase_2_-_Group_2.pptx
+++ b/docs/Phase_2_-_Group_2.pptx
@@ -5329,7 +5329,7 @@
 </file>
 
 <file path=ppt/slides/slide13.xml><?xml version="1.0" encoding="utf-8"?>
-<p:sld xmlns:a="http://schemas.openxmlformats.org/drawingml/2006/main" xmlns:r="http://schemas.openxmlformats.org/officeDocument/2006/relationships" xmlns:p="http://schemas.openxmlformats.org/presentationml/2006/main">
+<p:sld xmlns:a="http://schemas.openxmlformats.org/drawingml/2006/main" xmlns:p="http://schemas.openxmlformats.org/presentationml/2006/main" xmlns:r="http://schemas.openxmlformats.org/officeDocument/2006/relationships">
   <p:cSld>
     <p:spTree>
       <p:nvGrpSpPr>
@@ -5337,39 +5337,28 @@
         <p:cNvGrpSpPr/>
         <p:nvPr/>
       </p:nvGrpSpPr>
-      <p:grpSpPr>
-        <a:xfrm>
-          <a:off x="0" y="0"/>
-          <a:ext cx="0" cy="0"/>
-          <a:chOff x="0" y="0"/>
-          <a:chExt cx="0" cy="0"/>
-        </a:xfrm>
-      </p:grpSpPr>
+      <p:grpSpPr/>
       <p:sp>
         <p:nvSpPr>
-          <p:cNvPr id="170" name="Title 3"/>
-          <p:cNvSpPr txBox="1">
+          <p:cNvPr id="2" name="Title 1"/>
+          <p:cNvSpPr>
             <a:spLocks noGrp="1"/>
           </p:cNvSpPr>
           <p:nvPr>
             <p:ph type="title"/>
           </p:nvPr>
         </p:nvSpPr>
-        <p:spPr>
-          <a:xfrm>
-            <a:off x="838200" y="2263373"/>
-            <a:ext cx="10515600" cy="1325564"/>
-          </a:xfrm>
-          <a:prstGeom prst="rect">
-            <a:avLst/>
-          </a:prstGeom>
-        </p:spPr>
+        <p:spPr/>
         <p:txBody>
           <a:bodyPr/>
           <a:lstStyle/>
           <a:p>
             <a:r>
-              <a:t>Thank you</a:t>
+              <a:rPr>
+                <a:latin typeface="Times New Roman"/>
+                <a:cs typeface="Times New Roman"/>
+              </a:rPr>
+              <a:t>Phase 2: Progress Update</a:t>
             </a:r>
           </a:p>
         </p:txBody>
@@ -5379,7 +5368,6 @@
   <p:clrMapOvr>
     <a:masterClrMapping/>
   </p:clrMapOvr>
-  <p:transition spd="med"/>
 </p:sld>
 </file>
 
@@ -5413,49 +5401,6 @@
                 <a:latin typeface="Times New Roman"/>
                 <a:cs typeface="Times New Roman"/>
               </a:rPr>
-              <a:t>Phase 2: Progress Update</a:t>
-            </a:r>
-          </a:p>
-        </p:txBody>
-      </p:sp>
-    </p:spTree>
-  </p:cSld>
-  <p:clrMapOvr>
-    <a:masterClrMapping/>
-  </p:clrMapOvr>
-</p:sld>
-</file>
-
-<file path=ppt/slides/slide15.xml><?xml version="1.0" encoding="utf-8"?>
-<p:sld xmlns:a="http://schemas.openxmlformats.org/drawingml/2006/main" xmlns:p="http://schemas.openxmlformats.org/presentationml/2006/main" xmlns:r="http://schemas.openxmlformats.org/officeDocument/2006/relationships">
-  <p:cSld>
-    <p:spTree>
-      <p:nvGrpSpPr>
-        <p:cNvPr id="1" name=""/>
-        <p:cNvGrpSpPr/>
-        <p:nvPr/>
-      </p:nvGrpSpPr>
-      <p:grpSpPr/>
-      <p:sp>
-        <p:nvSpPr>
-          <p:cNvPr id="2" name="Title 1"/>
-          <p:cNvSpPr>
-            <a:spLocks noGrp="1"/>
-          </p:cNvSpPr>
-          <p:nvPr>
-            <p:ph type="title"/>
-          </p:nvPr>
-        </p:nvSpPr>
-        <p:spPr/>
-        <p:txBody>
-          <a:bodyPr/>
-          <a:lstStyle/>
-          <a:p>
-            <a:r>
-              <a:rPr>
-                <a:latin typeface="Times New Roman"/>
-                <a:cs typeface="Times New Roman"/>
-              </a:rPr>
               <a:t>Phase 2 Evaluation Agenda</a:t>
             </a:r>
           </a:p>
@@ -5580,7 +5525,7 @@
 </p:sld>
 </file>
 
-<file path=ppt/slides/slide16.xml><?xml version="1.0" encoding="utf-8"?>
+<file path=ppt/slides/slide15.xml><?xml version="1.0" encoding="utf-8"?>
 <p:sld xmlns:a="http://schemas.openxmlformats.org/drawingml/2006/main" xmlns:p="http://schemas.openxmlformats.org/presentationml/2006/main" xmlns:r="http://schemas.openxmlformats.org/officeDocument/2006/relationships">
   <p:cSld>
     <p:spTree>
@@ -6586,7 +6531,7 @@
 </p:sld>
 </file>
 
-<file path=ppt/slides/slide17.xml><?xml version="1.0" encoding="utf-8"?>
+<file path=ppt/slides/slide16.xml><?xml version="1.0" encoding="utf-8"?>
 <p:sld xmlns:a="http://schemas.openxmlformats.org/drawingml/2006/main" xmlns:p="http://schemas.openxmlformats.org/presentationml/2006/main" xmlns:r="http://schemas.openxmlformats.org/officeDocument/2006/relationships">
   <p:cSld>
     <p:spTree>
@@ -6944,7 +6889,7 @@
 </p:sld>
 </file>
 
-<file path=ppt/slides/slide18.xml><?xml version="1.0" encoding="utf-8"?>
+<file path=ppt/slides/slide17.xml><?xml version="1.0" encoding="utf-8"?>
 <p:sld xmlns:a="http://schemas.openxmlformats.org/drawingml/2006/main" xmlns:p="http://schemas.openxmlformats.org/presentationml/2006/main" xmlns:r="http://schemas.openxmlformats.org/officeDocument/2006/relationships">
   <p:cSld>
     <p:spTree>
@@ -7428,7 +7373,7 @@
 </p:sld>
 </file>
 
-<file path=ppt/slides/slide19.xml><?xml version="1.0" encoding="utf-8"?>
+<file path=ppt/slides/slide18.xml><?xml version="1.0" encoding="utf-8"?>
 <p:sld xmlns:a="http://schemas.openxmlformats.org/drawingml/2006/main" xmlns:p="http://schemas.openxmlformats.org/presentationml/2006/main" xmlns:r="http://schemas.openxmlformats.org/officeDocument/2006/relationships">
   <p:cSld>
     <p:spTree>
@@ -7915,6 +7860,244 @@
 </p:sld>
 </file>
 
+<file path=ppt/slides/slide19.xml><?xml version="1.0" encoding="utf-8"?>
+<p:sld xmlns:a="http://schemas.openxmlformats.org/drawingml/2006/main" xmlns:p="http://schemas.openxmlformats.org/presentationml/2006/main" xmlns:r="http://schemas.openxmlformats.org/officeDocument/2006/relationships">
+  <p:cSld>
+    <p:spTree>
+      <p:nvGrpSpPr>
+        <p:cNvPr id="1" name=""/>
+        <p:cNvGrpSpPr/>
+        <p:nvPr/>
+      </p:nvGrpSpPr>
+      <p:grpSpPr/>
+      <p:sp>
+        <p:nvSpPr>
+          <p:cNvPr id="2" name="Title 1"/>
+          <p:cNvSpPr>
+            <a:spLocks noGrp="1"/>
+          </p:cNvSpPr>
+          <p:nvPr>
+            <p:ph type="title"/>
+          </p:nvPr>
+        </p:nvSpPr>
+        <p:spPr/>
+        <p:txBody>
+          <a:bodyPr/>
+          <a:lstStyle/>
+          <a:p>
+            <a:r>
+              <a:rPr>
+                <a:latin typeface="Times New Roman"/>
+                <a:cs typeface="Times New Roman"/>
+              </a:rPr>
+              <a:t>Model Integration</a:t>
+            </a:r>
+          </a:p>
+        </p:txBody>
+      </p:sp>
+      <p:sp>
+        <p:nvSpPr>
+          <p:cNvPr id="3" name="Text Placeholder 2"/>
+          <p:cNvSpPr>
+            <a:spLocks noGrp="1"/>
+          </p:cNvSpPr>
+          <p:nvPr>
+            <p:ph type="body" idx="1"/>
+          </p:nvPr>
+        </p:nvSpPr>
+        <p:spPr>
+          <a:xfrm>
+            <a:off x="438912" y="1280160"/>
+            <a:ext cx="11338560" cy="3291840"/>
+          </a:xfrm>
+        </p:spPr>
+        <p:txBody>
+          <a:bodyPr/>
+          <a:lstStyle/>
+          <a:p>
+            <a:pPr>
+              <a:spcAft>
+                <a:spcPts val="1200"/>
+              </a:spcAft>
+            </a:pPr>
+            <a:r>
+              <a:rPr sz="2200" b="1">
+                <a:latin typeface="Times New Roman"/>
+                <a:cs typeface="Times New Roman"/>
+              </a:rPr>
+              <a:t>One config file </a:t>
+            </a:r>
+            <a:r>
+              <a:rPr sz="2200">
+                <a:latin typeface="Times New Roman"/>
+                <a:cs typeface="Times New Roman"/>
+              </a:rPr>
+              <a:t>drives the whole run.</a:t>
+            </a:r>
+          </a:p>
+          <a:p>
+            <a:pPr>
+              <a:spcAft>
+                <a:spcPts val="1200"/>
+              </a:spcAft>
+            </a:pPr>
+            <a:r>
+              <a:rPr sz="2200" b="1">
+                <a:latin typeface="Times New Roman"/>
+                <a:cs typeface="Times New Roman"/>
+              </a:rPr>
+              <a:t>Steps: </a:t>
+            </a:r>
+            <a:r>
+              <a:rPr sz="2200">
+                <a:latin typeface="Times New Roman"/>
+                <a:cs typeface="Times New Roman"/>
+              </a:rPr>
+              <a:t>load data, train, stream the test data and adapt, apply threshold, compute metrics, save.</a:t>
+            </a:r>
+          </a:p>
+          <a:p>
+            <a:pPr>
+              <a:spcAft>
+                <a:spcPts val="1200"/>
+              </a:spcAft>
+            </a:pPr>
+            <a:r>
+              <a:rPr sz="2200" b="1">
+                <a:latin typeface="Times New Roman"/>
+                <a:cs typeface="Times New Roman"/>
+              </a:rPr>
+              <a:t>Docker </a:t>
+            </a:r>
+            <a:r>
+              <a:rPr sz="2200">
+                <a:latin typeface="Times New Roman"/>
+                <a:cs typeface="Times New Roman"/>
+              </a:rPr>
+              <a:t>packages the environment, so it runs the same on any machine.</a:t>
+            </a:r>
+          </a:p>
+          <a:p>
+            <a:pPr>
+              <a:spcAft>
+                <a:spcPts val="1200"/>
+              </a:spcAft>
+            </a:pPr>
+            <a:r>
+              <a:rPr sz="2200" b="1">
+                <a:latin typeface="Times New Roman"/>
+                <a:cs typeface="Times New Roman"/>
+              </a:rPr>
+              <a:t>54 full runs </a:t>
+            </a:r>
+            <a:r>
+              <a:rPr sz="2200">
+                <a:latin typeface="Times New Roman"/>
+                <a:cs typeface="Times New Roman"/>
+              </a:rPr>
+              <a:t>(6 machines x 3 models x 3 seeds) and 6 quick runs completed.</a:t>
+            </a:r>
+          </a:p>
+          <a:p>
+            <a:pPr>
+              <a:spcAft>
+                <a:spcPts val="1200"/>
+              </a:spcAft>
+            </a:pPr>
+            <a:r>
+              <a:rPr sz="2200" b="1">
+                <a:latin typeface="Times New Roman"/>
+                <a:cs typeface="Times New Roman"/>
+              </a:rPr>
+              <a:t>22+ automated tests </a:t>
+            </a:r>
+            <a:r>
+              <a:rPr sz="2200">
+                <a:latin typeface="Times New Roman"/>
+                <a:cs typeface="Times New Roman"/>
+              </a:rPr>
+              <a:t>cover metrics, thresholds, windows and normalisation.</a:t>
+            </a:r>
+          </a:p>
+        </p:txBody>
+      </p:sp>
+      <p:sp>
+        <p:nvSpPr>
+          <p:cNvPr id="4" name="Rounded Rectangle 3"/>
+          <p:cNvSpPr/>
+          <p:nvPr/>
+        </p:nvSpPr>
+        <p:spPr>
+          <a:xfrm>
+            <a:off x="438912" y="4617720"/>
+            <a:ext cx="11247120" cy="1280160"/>
+          </a:xfrm>
+          <a:prstGeom prst="roundRect">
+            <a:avLst>
+              <a:gd name="adj" fmla="val 8000"/>
+            </a:avLst>
+          </a:prstGeom>
+          <a:solidFill>
+            <a:srgbClr val="FBEBE7"/>
+          </a:solidFill>
+          <a:ln>
+            <a:noFill/>
+          </a:ln>
+          <a:effectLst/>
+        </p:spPr>
+        <p:style>
+          <a:lnRef idx="1">
+            <a:schemeClr val="accent1"/>
+          </a:lnRef>
+          <a:fillRef idx="3">
+            <a:schemeClr val="accent1"/>
+          </a:fillRef>
+          <a:effectRef idx="2">
+            <a:schemeClr val="accent1"/>
+          </a:effectRef>
+          <a:fontRef idx="minor">
+            <a:schemeClr val="lt1"/>
+          </a:fontRef>
+        </p:style>
+        <p:txBody>
+          <a:bodyPr rtlCol="0" anchor="ctr" wrap="square" lIns="109728" rIns="109728" tIns="54864" bIns="54864"/>
+          <a:lstStyle/>
+          <a:p>
+            <a:pPr algn="l"/>
+            <a:r>
+              <a:rPr sz="1600" b="1">
+                <a:solidFill>
+                  <a:srgbClr val="000000"/>
+                </a:solidFill>
+                <a:latin typeface="Times New Roman"/>
+                <a:cs typeface="Times New Roman"/>
+              </a:rPr>
+              <a:t>Run it</a:t>
+            </a:r>
+          </a:p>
+          <a:p>
+            <a:pPr algn="l"/>
+            <a:r>
+              <a:rPr sz="1700" b="0">
+                <a:solidFill>
+                  <a:srgbClr val="000000"/>
+                </a:solidFill>
+                <a:latin typeface="Times New Roman"/>
+                <a:cs typeface="Times New Roman"/>
+              </a:rPr>
+              <a:t>docker compose run --rm data     |     quick     |     smd     |     compare</a:t>
+            </a:r>
+          </a:p>
+        </p:txBody>
+      </p:sp>
+    </p:spTree>
+  </p:cSld>
+  <p:clrMapOvr>
+    <a:masterClrMapping/>
+  </p:clrMapOvr>
+</p:sld>
+</file>
+
 <file path=ppt/slides/slide2.xml><?xml version="1.0" encoding="utf-8"?>
 <p:sld xmlns:a="http://schemas.openxmlformats.org/drawingml/2006/main" xmlns:r="http://schemas.openxmlformats.org/officeDocument/2006/relationships" xmlns:p="http://schemas.openxmlformats.org/presentationml/2006/main">
   <p:cSld>
@@ -8320,244 +8503,6 @@
 </file>
 
 <file path=ppt/slides/slide20.xml><?xml version="1.0" encoding="utf-8"?>
-<p:sld xmlns:a="http://schemas.openxmlformats.org/drawingml/2006/main" xmlns:p="http://schemas.openxmlformats.org/presentationml/2006/main" xmlns:r="http://schemas.openxmlformats.org/officeDocument/2006/relationships">
-  <p:cSld>
-    <p:spTree>
-      <p:nvGrpSpPr>
-        <p:cNvPr id="1" name=""/>
-        <p:cNvGrpSpPr/>
-        <p:nvPr/>
-      </p:nvGrpSpPr>
-      <p:grpSpPr/>
-      <p:sp>
-        <p:nvSpPr>
-          <p:cNvPr id="2" name="Title 1"/>
-          <p:cNvSpPr>
-            <a:spLocks noGrp="1"/>
-          </p:cNvSpPr>
-          <p:nvPr>
-            <p:ph type="title"/>
-          </p:nvPr>
-        </p:nvSpPr>
-        <p:spPr/>
-        <p:txBody>
-          <a:bodyPr/>
-          <a:lstStyle/>
-          <a:p>
-            <a:r>
-              <a:rPr>
-                <a:latin typeface="Times New Roman"/>
-                <a:cs typeface="Times New Roman"/>
-              </a:rPr>
-              <a:t>Model Integration</a:t>
-            </a:r>
-          </a:p>
-        </p:txBody>
-      </p:sp>
-      <p:sp>
-        <p:nvSpPr>
-          <p:cNvPr id="3" name="Text Placeholder 2"/>
-          <p:cNvSpPr>
-            <a:spLocks noGrp="1"/>
-          </p:cNvSpPr>
-          <p:nvPr>
-            <p:ph type="body" idx="1"/>
-          </p:nvPr>
-        </p:nvSpPr>
-        <p:spPr>
-          <a:xfrm>
-            <a:off x="438912" y="1280160"/>
-            <a:ext cx="11338560" cy="3291840"/>
-          </a:xfrm>
-        </p:spPr>
-        <p:txBody>
-          <a:bodyPr/>
-          <a:lstStyle/>
-          <a:p>
-            <a:pPr>
-              <a:spcAft>
-                <a:spcPts val="1200"/>
-              </a:spcAft>
-            </a:pPr>
-            <a:r>
-              <a:rPr sz="2200" b="1">
-                <a:latin typeface="Times New Roman"/>
-                <a:cs typeface="Times New Roman"/>
-              </a:rPr>
-              <a:t>One config file </a:t>
-            </a:r>
-            <a:r>
-              <a:rPr sz="2200">
-                <a:latin typeface="Times New Roman"/>
-                <a:cs typeface="Times New Roman"/>
-              </a:rPr>
-              <a:t>drives the whole run.</a:t>
-            </a:r>
-          </a:p>
-          <a:p>
-            <a:pPr>
-              <a:spcAft>
-                <a:spcPts val="1200"/>
-              </a:spcAft>
-            </a:pPr>
-            <a:r>
-              <a:rPr sz="2200" b="1">
-                <a:latin typeface="Times New Roman"/>
-                <a:cs typeface="Times New Roman"/>
-              </a:rPr>
-              <a:t>Steps: </a:t>
-            </a:r>
-            <a:r>
-              <a:rPr sz="2200">
-                <a:latin typeface="Times New Roman"/>
-                <a:cs typeface="Times New Roman"/>
-              </a:rPr>
-              <a:t>load data, train, stream the test data and adapt, apply threshold, compute metrics, save.</a:t>
-            </a:r>
-          </a:p>
-          <a:p>
-            <a:pPr>
-              <a:spcAft>
-                <a:spcPts val="1200"/>
-              </a:spcAft>
-            </a:pPr>
-            <a:r>
-              <a:rPr sz="2200" b="1">
-                <a:latin typeface="Times New Roman"/>
-                <a:cs typeface="Times New Roman"/>
-              </a:rPr>
-              <a:t>Docker </a:t>
-            </a:r>
-            <a:r>
-              <a:rPr sz="2200">
-                <a:latin typeface="Times New Roman"/>
-                <a:cs typeface="Times New Roman"/>
-              </a:rPr>
-              <a:t>packages the environment, so it runs the same on any machine.</a:t>
-            </a:r>
-          </a:p>
-          <a:p>
-            <a:pPr>
-              <a:spcAft>
-                <a:spcPts val="1200"/>
-              </a:spcAft>
-            </a:pPr>
-            <a:r>
-              <a:rPr sz="2200" b="1">
-                <a:latin typeface="Times New Roman"/>
-                <a:cs typeface="Times New Roman"/>
-              </a:rPr>
-              <a:t>54 full runs </a:t>
-            </a:r>
-            <a:r>
-              <a:rPr sz="2200">
-                <a:latin typeface="Times New Roman"/>
-                <a:cs typeface="Times New Roman"/>
-              </a:rPr>
-              <a:t>(6 machines x 3 models x 3 seeds) and 6 quick runs completed.</a:t>
-            </a:r>
-          </a:p>
-          <a:p>
-            <a:pPr>
-              <a:spcAft>
-                <a:spcPts val="1200"/>
-              </a:spcAft>
-            </a:pPr>
-            <a:r>
-              <a:rPr sz="2200" b="1">
-                <a:latin typeface="Times New Roman"/>
-                <a:cs typeface="Times New Roman"/>
-              </a:rPr>
-              <a:t>22+ automated tests </a:t>
-            </a:r>
-            <a:r>
-              <a:rPr sz="2200">
-                <a:latin typeface="Times New Roman"/>
-                <a:cs typeface="Times New Roman"/>
-              </a:rPr>
-              <a:t>cover metrics, thresholds, windows and normalisation.</a:t>
-            </a:r>
-          </a:p>
-        </p:txBody>
-      </p:sp>
-      <p:sp>
-        <p:nvSpPr>
-          <p:cNvPr id="4" name="Rounded Rectangle 3"/>
-          <p:cNvSpPr/>
-          <p:nvPr/>
-        </p:nvSpPr>
-        <p:spPr>
-          <a:xfrm>
-            <a:off x="438912" y="4617720"/>
-            <a:ext cx="11247120" cy="1280160"/>
-          </a:xfrm>
-          <a:prstGeom prst="roundRect">
-            <a:avLst>
-              <a:gd name="adj" fmla="val 8000"/>
-            </a:avLst>
-          </a:prstGeom>
-          <a:solidFill>
-            <a:srgbClr val="FBEBE7"/>
-          </a:solidFill>
-          <a:ln>
-            <a:noFill/>
-          </a:ln>
-          <a:effectLst/>
-        </p:spPr>
-        <p:style>
-          <a:lnRef idx="1">
-            <a:schemeClr val="accent1"/>
-          </a:lnRef>
-          <a:fillRef idx="3">
-            <a:schemeClr val="accent1"/>
-          </a:fillRef>
-          <a:effectRef idx="2">
-            <a:schemeClr val="accent1"/>
-          </a:effectRef>
-          <a:fontRef idx="minor">
-            <a:schemeClr val="lt1"/>
-          </a:fontRef>
-        </p:style>
-        <p:txBody>
-          <a:bodyPr rtlCol="0" anchor="ctr" wrap="square" lIns="109728" rIns="109728" tIns="54864" bIns="54864"/>
-          <a:lstStyle/>
-          <a:p>
-            <a:pPr algn="l"/>
-            <a:r>
-              <a:rPr sz="1600" b="1">
-                <a:solidFill>
-                  <a:srgbClr val="000000"/>
-                </a:solidFill>
-                <a:latin typeface="Times New Roman"/>
-                <a:cs typeface="Times New Roman"/>
-              </a:rPr>
-              <a:t>Run it</a:t>
-            </a:r>
-          </a:p>
-          <a:p>
-            <a:pPr algn="l"/>
-            <a:r>
-              <a:rPr sz="1700" b="0">
-                <a:solidFill>
-                  <a:srgbClr val="000000"/>
-                </a:solidFill>
-                <a:latin typeface="Times New Roman"/>
-                <a:cs typeface="Times New Roman"/>
-              </a:rPr>
-              <a:t>docker compose run --rm data     |     quick     |     smd     |     compare</a:t>
-            </a:r>
-          </a:p>
-        </p:txBody>
-      </p:sp>
-    </p:spTree>
-  </p:cSld>
-  <p:clrMapOvr>
-    <a:masterClrMapping/>
-  </p:clrMapOvr>
-</p:sld>
-</file>
-
-<file path=ppt/slides/slide21.xml><?xml version="1.0" encoding="utf-8"?>
 <p:sld xmlns:a="http://schemas.openxmlformats.org/drawingml/2006/main" xmlns:p="http://schemas.openxmlformats.org/presentationml/2006/main" xmlns:r="http://schemas.openxmlformats.org/officeDocument/2006/relationships">
   <p:cSld>
     <p:spTree>
@@ -9151,7 +9096,7 @@
 </p:sld>
 </file>
 
-<file path=ppt/slides/slide22.xml><?xml version="1.0" encoding="utf-8"?>
+<file path=ppt/slides/slide21.xml><?xml version="1.0" encoding="utf-8"?>
 <p:sld xmlns:a="http://schemas.openxmlformats.org/drawingml/2006/main" xmlns:p="http://schemas.openxmlformats.org/presentationml/2006/main" xmlns:r="http://schemas.openxmlformats.org/officeDocument/2006/relationships">
   <p:cSld>
     <p:spTree>
@@ -9430,7 +9375,7 @@
 </p:sld>
 </file>
 
-<file path=ppt/slides/slide23.xml><?xml version="1.0" encoding="utf-8"?>
+<file path=ppt/slides/slide22.xml><?xml version="1.0" encoding="utf-8"?>
 <p:sld xmlns:a="http://schemas.openxmlformats.org/drawingml/2006/main" xmlns:p="http://schemas.openxmlformats.org/presentationml/2006/main" xmlns:r="http://schemas.openxmlformats.org/officeDocument/2006/relationships">
   <p:cSld>
     <p:spTree>
@@ -9586,7 +9531,7 @@
 </p:sld>
 </file>
 
-<file path=ppt/slides/slide24.xml><?xml version="1.0" encoding="utf-8"?>
+<file path=ppt/slides/slide23.xml><?xml version="1.0" encoding="utf-8"?>
 <p:sld xmlns:a="http://schemas.openxmlformats.org/drawingml/2006/main" xmlns:p="http://schemas.openxmlformats.org/presentationml/2006/main" xmlns:r="http://schemas.openxmlformats.org/officeDocument/2006/relationships">
   <p:cSld>
     <p:spTree>
@@ -9755,7 +9700,7 @@
 </p:sld>
 </file>
 
-<file path=ppt/slides/slide25.xml><?xml version="1.0" encoding="utf-8"?>
+<file path=ppt/slides/slide24.xml><?xml version="1.0" encoding="utf-8"?>
 <p:sld xmlns:a="http://schemas.openxmlformats.org/drawingml/2006/main" xmlns:p="http://schemas.openxmlformats.org/presentationml/2006/main" xmlns:r="http://schemas.openxmlformats.org/officeDocument/2006/relationships">
   <p:cSld>
     <p:spTree>
@@ -9827,7 +9772,7 @@
                 <a:latin typeface="Times New Roman"/>
                 <a:cs typeface="Times New Roman"/>
               </a:rPr>
-              <a:t>github.com/PuravPatil/test-time-adaptation-tsad</a:t>
+              <a:t>github.com/PuravPatil/test-time-adaptation-tsad1</a:t>
             </a:r>
           </a:p>
           <a:p>
@@ -9924,7 +9869,7 @@
 </p:sld>
 </file>
 
-<file path=ppt/slides/slide26.xml><?xml version="1.0" encoding="utf-8"?>
+<file path=ppt/slides/slide25.xml><?xml version="1.0" encoding="utf-8"?>
 <p:sld xmlns:a="http://schemas.openxmlformats.org/drawingml/2006/main" xmlns:p="http://schemas.openxmlformats.org/presentationml/2006/main" xmlns:r="http://schemas.openxmlformats.org/officeDocument/2006/relationships">
   <p:cSld>
     <p:spTree>
@@ -10413,7 +10358,7 @@
 </p:sld>
 </file>
 
-<file path=ppt/slides/slide27.xml><?xml version="1.0" encoding="utf-8"?>
+<file path=ppt/slides/slide26.xml><?xml version="1.0" encoding="utf-8"?>
 <p:sld xmlns:a="http://schemas.openxmlformats.org/drawingml/2006/main" xmlns:p="http://schemas.openxmlformats.org/presentationml/2006/main" xmlns:r="http://schemas.openxmlformats.org/officeDocument/2006/relationships">
   <p:cSld>
     <p:spTree>
@@ -10600,6 +10545,61 @@
   <p:clrMapOvr>
     <a:masterClrMapping/>
   </p:clrMapOvr>
+</p:sld>
+</file>
+
+<file path=ppt/slides/slide27.xml><?xml version="1.0" encoding="utf-8"?>
+<p:sld xmlns:a="http://schemas.openxmlformats.org/drawingml/2006/main" xmlns:r="http://schemas.openxmlformats.org/officeDocument/2006/relationships" xmlns:p="http://schemas.openxmlformats.org/presentationml/2006/main">
+  <p:cSld>
+    <p:spTree>
+      <p:nvGrpSpPr>
+        <p:cNvPr id="1" name=""/>
+        <p:cNvGrpSpPr/>
+        <p:nvPr/>
+      </p:nvGrpSpPr>
+      <p:grpSpPr>
+        <a:xfrm>
+          <a:off x="0" y="0"/>
+          <a:ext cx="0" cy="0"/>
+          <a:chOff x="0" y="0"/>
+          <a:chExt cx="0" cy="0"/>
+        </a:xfrm>
+      </p:grpSpPr>
+      <p:sp>
+        <p:nvSpPr>
+          <p:cNvPr id="170" name="Title 3"/>
+          <p:cNvSpPr txBox="1">
+            <a:spLocks noGrp="1"/>
+          </p:cNvSpPr>
+          <p:nvPr>
+            <p:ph type="title"/>
+          </p:nvPr>
+        </p:nvSpPr>
+        <p:spPr>
+          <a:xfrm>
+            <a:off x="838200" y="2263373"/>
+            <a:ext cx="10515600" cy="1325564"/>
+          </a:xfrm>
+          <a:prstGeom prst="rect">
+            <a:avLst/>
+          </a:prstGeom>
+        </p:spPr>
+        <p:txBody>
+          <a:bodyPr/>
+          <a:lstStyle/>
+          <a:p>
+            <a:r>
+              <a:t>Thank you</a:t>
+            </a:r>
+          </a:p>
+        </p:txBody>
+      </p:sp>
+    </p:spTree>
+  </p:cSld>
+  <p:clrMapOvr>
+    <a:masterClrMapping/>
+  </p:clrMapOvr>
+  <p:transition spd="med"/>
 </p:sld>
 </file>
 

</xml_diff>

<commit_message>
Update Phase 2 deck
Co-Authored-By: Claude Opus 5.5 <noreply@anthropic.com>
Claude-Session: https://claude.ai/code/session_015Rdq174rNwUStoqdUX553D
</commit_message>
<xml_diff>
--- a/docs/Phase_2_-_Group_2.pptx
+++ b/docs/Phase_2_-_Group_2.pptx
@@ -5329,7 +5329,7 @@
 </file>
 
 <file path=ppt/slides/slide13.xml><?xml version="1.0" encoding="utf-8"?>
-<p:sld xmlns:a="http://schemas.openxmlformats.org/drawingml/2006/main" xmlns:r="http://schemas.openxmlformats.org/officeDocument/2006/relationships" xmlns:p="http://schemas.openxmlformats.org/presentationml/2006/main">
+<p:sld xmlns:a="http://schemas.openxmlformats.org/drawingml/2006/main" xmlns:p="http://schemas.openxmlformats.org/presentationml/2006/main" xmlns:r="http://schemas.openxmlformats.org/officeDocument/2006/relationships">
   <p:cSld>
     <p:spTree>
       <p:nvGrpSpPr>
@@ -5337,39 +5337,28 @@
         <p:cNvGrpSpPr/>
         <p:nvPr/>
       </p:nvGrpSpPr>
-      <p:grpSpPr>
-        <a:xfrm>
-          <a:off x="0" y="0"/>
-          <a:ext cx="0" cy="0"/>
-          <a:chOff x="0" y="0"/>
-          <a:chExt cx="0" cy="0"/>
-        </a:xfrm>
-      </p:grpSpPr>
+      <p:grpSpPr/>
       <p:sp>
         <p:nvSpPr>
-          <p:cNvPr id="170" name="Title 3"/>
-          <p:cNvSpPr txBox="1">
+          <p:cNvPr id="2" name="Title 1"/>
+          <p:cNvSpPr>
             <a:spLocks noGrp="1"/>
           </p:cNvSpPr>
           <p:nvPr>
             <p:ph type="title"/>
           </p:nvPr>
         </p:nvSpPr>
-        <p:spPr>
-          <a:xfrm>
-            <a:off x="838200" y="2263373"/>
-            <a:ext cx="10515600" cy="1325564"/>
-          </a:xfrm>
-          <a:prstGeom prst="rect">
-            <a:avLst/>
-          </a:prstGeom>
-        </p:spPr>
+        <p:spPr/>
         <p:txBody>
           <a:bodyPr/>
           <a:lstStyle/>
           <a:p>
             <a:r>
-              <a:t>Thank you</a:t>
+              <a:rPr>
+                <a:latin typeface="Times New Roman"/>
+                <a:cs typeface="Times New Roman"/>
+              </a:rPr>
+              <a:t>Phase 2: Progress Update</a:t>
             </a:r>
           </a:p>
         </p:txBody>
@@ -5379,7 +5368,6 @@
   <p:clrMapOvr>
     <a:masterClrMapping/>
   </p:clrMapOvr>
-  <p:transition spd="med"/>
 </p:sld>
 </file>
 
@@ -5413,49 +5401,6 @@
                 <a:latin typeface="Times New Roman"/>
                 <a:cs typeface="Times New Roman"/>
               </a:rPr>
-              <a:t>Phase 2: Progress Update</a:t>
-            </a:r>
-          </a:p>
-        </p:txBody>
-      </p:sp>
-    </p:spTree>
-  </p:cSld>
-  <p:clrMapOvr>
-    <a:masterClrMapping/>
-  </p:clrMapOvr>
-</p:sld>
-</file>
-
-<file path=ppt/slides/slide15.xml><?xml version="1.0" encoding="utf-8"?>
-<p:sld xmlns:a="http://schemas.openxmlformats.org/drawingml/2006/main" xmlns:p="http://schemas.openxmlformats.org/presentationml/2006/main" xmlns:r="http://schemas.openxmlformats.org/officeDocument/2006/relationships">
-  <p:cSld>
-    <p:spTree>
-      <p:nvGrpSpPr>
-        <p:cNvPr id="1" name=""/>
-        <p:cNvGrpSpPr/>
-        <p:nvPr/>
-      </p:nvGrpSpPr>
-      <p:grpSpPr/>
-      <p:sp>
-        <p:nvSpPr>
-          <p:cNvPr id="2" name="Title 1"/>
-          <p:cNvSpPr>
-            <a:spLocks noGrp="1"/>
-          </p:cNvSpPr>
-          <p:nvPr>
-            <p:ph type="title"/>
-          </p:nvPr>
-        </p:nvSpPr>
-        <p:spPr/>
-        <p:txBody>
-          <a:bodyPr/>
-          <a:lstStyle/>
-          <a:p>
-            <a:r>
-              <a:rPr>
-                <a:latin typeface="Times New Roman"/>
-                <a:cs typeface="Times New Roman"/>
-              </a:rPr>
               <a:t>Phase 2 Evaluation Agenda</a:t>
             </a:r>
           </a:p>
@@ -5580,7 +5525,7 @@
 </p:sld>
 </file>
 
-<file path=ppt/slides/slide16.xml><?xml version="1.0" encoding="utf-8"?>
+<file path=ppt/slides/slide15.xml><?xml version="1.0" encoding="utf-8"?>
 <p:sld xmlns:a="http://schemas.openxmlformats.org/drawingml/2006/main" xmlns:p="http://schemas.openxmlformats.org/presentationml/2006/main" xmlns:r="http://schemas.openxmlformats.org/officeDocument/2006/relationships">
   <p:cSld>
     <p:spTree>
@@ -6586,7 +6531,7 @@
 </p:sld>
 </file>
 
-<file path=ppt/slides/slide17.xml><?xml version="1.0" encoding="utf-8"?>
+<file path=ppt/slides/slide16.xml><?xml version="1.0" encoding="utf-8"?>
 <p:sld xmlns:a="http://schemas.openxmlformats.org/drawingml/2006/main" xmlns:p="http://schemas.openxmlformats.org/presentationml/2006/main" xmlns:r="http://schemas.openxmlformats.org/officeDocument/2006/relationships">
   <p:cSld>
     <p:spTree>
@@ -6944,7 +6889,7 @@
 </p:sld>
 </file>
 
-<file path=ppt/slides/slide18.xml><?xml version="1.0" encoding="utf-8"?>
+<file path=ppt/slides/slide17.xml><?xml version="1.0" encoding="utf-8"?>
 <p:sld xmlns:a="http://schemas.openxmlformats.org/drawingml/2006/main" xmlns:p="http://schemas.openxmlformats.org/presentationml/2006/main" xmlns:r="http://schemas.openxmlformats.org/officeDocument/2006/relationships">
   <p:cSld>
     <p:spTree>
@@ -7428,7 +7373,7 @@
 </p:sld>
 </file>
 
-<file path=ppt/slides/slide19.xml><?xml version="1.0" encoding="utf-8"?>
+<file path=ppt/slides/slide18.xml><?xml version="1.0" encoding="utf-8"?>
 <p:sld xmlns:a="http://schemas.openxmlformats.org/drawingml/2006/main" xmlns:p="http://schemas.openxmlformats.org/presentationml/2006/main" xmlns:r="http://schemas.openxmlformats.org/officeDocument/2006/relationships">
   <p:cSld>
     <p:spTree>
@@ -7915,6 +7860,244 @@
 </p:sld>
 </file>
 
+<file path=ppt/slides/slide19.xml><?xml version="1.0" encoding="utf-8"?>
+<p:sld xmlns:a="http://schemas.openxmlformats.org/drawingml/2006/main" xmlns:p="http://schemas.openxmlformats.org/presentationml/2006/main" xmlns:r="http://schemas.openxmlformats.org/officeDocument/2006/relationships">
+  <p:cSld>
+    <p:spTree>
+      <p:nvGrpSpPr>
+        <p:cNvPr id="1" name=""/>
+        <p:cNvGrpSpPr/>
+        <p:nvPr/>
+      </p:nvGrpSpPr>
+      <p:grpSpPr/>
+      <p:sp>
+        <p:nvSpPr>
+          <p:cNvPr id="2" name="Title 1"/>
+          <p:cNvSpPr>
+            <a:spLocks noGrp="1"/>
+          </p:cNvSpPr>
+          <p:nvPr>
+            <p:ph type="title"/>
+          </p:nvPr>
+        </p:nvSpPr>
+        <p:spPr/>
+        <p:txBody>
+          <a:bodyPr/>
+          <a:lstStyle/>
+          <a:p>
+            <a:r>
+              <a:rPr>
+                <a:latin typeface="Times New Roman"/>
+                <a:cs typeface="Times New Roman"/>
+              </a:rPr>
+              <a:t>Model Integration</a:t>
+            </a:r>
+          </a:p>
+        </p:txBody>
+      </p:sp>
+      <p:sp>
+        <p:nvSpPr>
+          <p:cNvPr id="3" name="Text Placeholder 2"/>
+          <p:cNvSpPr>
+            <a:spLocks noGrp="1"/>
+          </p:cNvSpPr>
+          <p:nvPr>
+            <p:ph type="body" idx="1"/>
+          </p:nvPr>
+        </p:nvSpPr>
+        <p:spPr>
+          <a:xfrm>
+            <a:off x="438912" y="1280160"/>
+            <a:ext cx="11338560" cy="3291840"/>
+          </a:xfrm>
+        </p:spPr>
+        <p:txBody>
+          <a:bodyPr/>
+          <a:lstStyle/>
+          <a:p>
+            <a:pPr>
+              <a:spcAft>
+                <a:spcPts val="1200"/>
+              </a:spcAft>
+            </a:pPr>
+            <a:r>
+              <a:rPr sz="2200" b="1">
+                <a:latin typeface="Times New Roman"/>
+                <a:cs typeface="Times New Roman"/>
+              </a:rPr>
+              <a:t>One config file </a:t>
+            </a:r>
+            <a:r>
+              <a:rPr sz="2200">
+                <a:latin typeface="Times New Roman"/>
+                <a:cs typeface="Times New Roman"/>
+              </a:rPr>
+              <a:t>drives the whole run.</a:t>
+            </a:r>
+          </a:p>
+          <a:p>
+            <a:pPr>
+              <a:spcAft>
+                <a:spcPts val="1200"/>
+              </a:spcAft>
+            </a:pPr>
+            <a:r>
+              <a:rPr sz="2200" b="1">
+                <a:latin typeface="Times New Roman"/>
+                <a:cs typeface="Times New Roman"/>
+              </a:rPr>
+              <a:t>Steps: </a:t>
+            </a:r>
+            <a:r>
+              <a:rPr sz="2200">
+                <a:latin typeface="Times New Roman"/>
+                <a:cs typeface="Times New Roman"/>
+              </a:rPr>
+              <a:t>load data, train, stream the test data and adapt, apply threshold, compute metrics, save.</a:t>
+            </a:r>
+          </a:p>
+          <a:p>
+            <a:pPr>
+              <a:spcAft>
+                <a:spcPts val="1200"/>
+              </a:spcAft>
+            </a:pPr>
+            <a:r>
+              <a:rPr sz="2200" b="1">
+                <a:latin typeface="Times New Roman"/>
+                <a:cs typeface="Times New Roman"/>
+              </a:rPr>
+              <a:t>Docker </a:t>
+            </a:r>
+            <a:r>
+              <a:rPr sz="2200">
+                <a:latin typeface="Times New Roman"/>
+                <a:cs typeface="Times New Roman"/>
+              </a:rPr>
+              <a:t>packages the environment, so it runs the same on any machine.</a:t>
+            </a:r>
+          </a:p>
+          <a:p>
+            <a:pPr>
+              <a:spcAft>
+                <a:spcPts val="1200"/>
+              </a:spcAft>
+            </a:pPr>
+            <a:r>
+              <a:rPr sz="2200" b="1">
+                <a:latin typeface="Times New Roman"/>
+                <a:cs typeface="Times New Roman"/>
+              </a:rPr>
+              <a:t>54 full runs </a:t>
+            </a:r>
+            <a:r>
+              <a:rPr sz="2200">
+                <a:latin typeface="Times New Roman"/>
+                <a:cs typeface="Times New Roman"/>
+              </a:rPr>
+              <a:t>(6 machines x 3 models x 3 seeds) and 6 quick runs completed.</a:t>
+            </a:r>
+          </a:p>
+          <a:p>
+            <a:pPr>
+              <a:spcAft>
+                <a:spcPts val="1200"/>
+              </a:spcAft>
+            </a:pPr>
+            <a:r>
+              <a:rPr sz="2200" b="1">
+                <a:latin typeface="Times New Roman"/>
+                <a:cs typeface="Times New Roman"/>
+              </a:rPr>
+              <a:t>22+ automated tests </a:t>
+            </a:r>
+            <a:r>
+              <a:rPr sz="2200">
+                <a:latin typeface="Times New Roman"/>
+                <a:cs typeface="Times New Roman"/>
+              </a:rPr>
+              <a:t>cover metrics, thresholds, windows and normalisation.</a:t>
+            </a:r>
+          </a:p>
+        </p:txBody>
+      </p:sp>
+      <p:sp>
+        <p:nvSpPr>
+          <p:cNvPr id="4" name="Rounded Rectangle 3"/>
+          <p:cNvSpPr/>
+          <p:nvPr/>
+        </p:nvSpPr>
+        <p:spPr>
+          <a:xfrm>
+            <a:off x="438912" y="4617720"/>
+            <a:ext cx="11247120" cy="1280160"/>
+          </a:xfrm>
+          <a:prstGeom prst="roundRect">
+            <a:avLst>
+              <a:gd name="adj" fmla="val 8000"/>
+            </a:avLst>
+          </a:prstGeom>
+          <a:solidFill>
+            <a:srgbClr val="FBEBE7"/>
+          </a:solidFill>
+          <a:ln>
+            <a:noFill/>
+          </a:ln>
+          <a:effectLst/>
+        </p:spPr>
+        <p:style>
+          <a:lnRef idx="1">
+            <a:schemeClr val="accent1"/>
+          </a:lnRef>
+          <a:fillRef idx="3">
+            <a:schemeClr val="accent1"/>
+          </a:fillRef>
+          <a:effectRef idx="2">
+            <a:schemeClr val="accent1"/>
+          </a:effectRef>
+          <a:fontRef idx="minor">
+            <a:schemeClr val="lt1"/>
+          </a:fontRef>
+        </p:style>
+        <p:txBody>
+          <a:bodyPr rtlCol="0" anchor="ctr" wrap="square" lIns="109728" rIns="109728" tIns="54864" bIns="54864"/>
+          <a:lstStyle/>
+          <a:p>
+            <a:pPr algn="l"/>
+            <a:r>
+              <a:rPr sz="1600" b="1">
+                <a:solidFill>
+                  <a:srgbClr val="000000"/>
+                </a:solidFill>
+                <a:latin typeface="Times New Roman"/>
+                <a:cs typeface="Times New Roman"/>
+              </a:rPr>
+              <a:t>Run it</a:t>
+            </a:r>
+          </a:p>
+          <a:p>
+            <a:pPr algn="l"/>
+            <a:r>
+              <a:rPr sz="1700" b="0">
+                <a:solidFill>
+                  <a:srgbClr val="000000"/>
+                </a:solidFill>
+                <a:latin typeface="Times New Roman"/>
+                <a:cs typeface="Times New Roman"/>
+              </a:rPr>
+              <a:t>docker compose run --rm data     |     quick     |     smd     |     compare</a:t>
+            </a:r>
+          </a:p>
+        </p:txBody>
+      </p:sp>
+    </p:spTree>
+  </p:cSld>
+  <p:clrMapOvr>
+    <a:masterClrMapping/>
+  </p:clrMapOvr>
+</p:sld>
+</file>
+
 <file path=ppt/slides/slide2.xml><?xml version="1.0" encoding="utf-8"?>
 <p:sld xmlns:a="http://schemas.openxmlformats.org/drawingml/2006/main" xmlns:r="http://schemas.openxmlformats.org/officeDocument/2006/relationships" xmlns:p="http://schemas.openxmlformats.org/presentationml/2006/main">
   <p:cSld>
@@ -8320,244 +8503,6 @@
 </file>
 
 <file path=ppt/slides/slide20.xml><?xml version="1.0" encoding="utf-8"?>
-<p:sld xmlns:a="http://schemas.openxmlformats.org/drawingml/2006/main" xmlns:p="http://schemas.openxmlformats.org/presentationml/2006/main" xmlns:r="http://schemas.openxmlformats.org/officeDocument/2006/relationships">
-  <p:cSld>
-    <p:spTree>
-      <p:nvGrpSpPr>
-        <p:cNvPr id="1" name=""/>
-        <p:cNvGrpSpPr/>
-        <p:nvPr/>
-      </p:nvGrpSpPr>
-      <p:grpSpPr/>
-      <p:sp>
-        <p:nvSpPr>
-          <p:cNvPr id="2" name="Title 1"/>
-          <p:cNvSpPr>
-            <a:spLocks noGrp="1"/>
-          </p:cNvSpPr>
-          <p:nvPr>
-            <p:ph type="title"/>
-          </p:nvPr>
-        </p:nvSpPr>
-        <p:spPr/>
-        <p:txBody>
-          <a:bodyPr/>
-          <a:lstStyle/>
-          <a:p>
-            <a:r>
-              <a:rPr>
-                <a:latin typeface="Times New Roman"/>
-                <a:cs typeface="Times New Roman"/>
-              </a:rPr>
-              <a:t>Model Integration</a:t>
-            </a:r>
-          </a:p>
-        </p:txBody>
-      </p:sp>
-      <p:sp>
-        <p:nvSpPr>
-          <p:cNvPr id="3" name="Text Placeholder 2"/>
-          <p:cNvSpPr>
-            <a:spLocks noGrp="1"/>
-          </p:cNvSpPr>
-          <p:nvPr>
-            <p:ph type="body" idx="1"/>
-          </p:nvPr>
-        </p:nvSpPr>
-        <p:spPr>
-          <a:xfrm>
-            <a:off x="438912" y="1280160"/>
-            <a:ext cx="11338560" cy="3291840"/>
-          </a:xfrm>
-        </p:spPr>
-        <p:txBody>
-          <a:bodyPr/>
-          <a:lstStyle/>
-          <a:p>
-            <a:pPr>
-              <a:spcAft>
-                <a:spcPts val="1200"/>
-              </a:spcAft>
-            </a:pPr>
-            <a:r>
-              <a:rPr sz="2200" b="1">
-                <a:latin typeface="Times New Roman"/>
-                <a:cs typeface="Times New Roman"/>
-              </a:rPr>
-              <a:t>One config file </a:t>
-            </a:r>
-            <a:r>
-              <a:rPr sz="2200">
-                <a:latin typeface="Times New Roman"/>
-                <a:cs typeface="Times New Roman"/>
-              </a:rPr>
-              <a:t>drives the whole run.</a:t>
-            </a:r>
-          </a:p>
-          <a:p>
-            <a:pPr>
-              <a:spcAft>
-                <a:spcPts val="1200"/>
-              </a:spcAft>
-            </a:pPr>
-            <a:r>
-              <a:rPr sz="2200" b="1">
-                <a:latin typeface="Times New Roman"/>
-                <a:cs typeface="Times New Roman"/>
-              </a:rPr>
-              <a:t>Steps: </a:t>
-            </a:r>
-            <a:r>
-              <a:rPr sz="2200">
-                <a:latin typeface="Times New Roman"/>
-                <a:cs typeface="Times New Roman"/>
-              </a:rPr>
-              <a:t>load data, train, stream the test data and adapt, apply threshold, compute metrics, save.</a:t>
-            </a:r>
-          </a:p>
-          <a:p>
-            <a:pPr>
-              <a:spcAft>
-                <a:spcPts val="1200"/>
-              </a:spcAft>
-            </a:pPr>
-            <a:r>
-              <a:rPr sz="2200" b="1">
-                <a:latin typeface="Times New Roman"/>
-                <a:cs typeface="Times New Roman"/>
-              </a:rPr>
-              <a:t>Docker </a:t>
-            </a:r>
-            <a:r>
-              <a:rPr sz="2200">
-                <a:latin typeface="Times New Roman"/>
-                <a:cs typeface="Times New Roman"/>
-              </a:rPr>
-              <a:t>packages the environment, so it runs the same on any machine.</a:t>
-            </a:r>
-          </a:p>
-          <a:p>
-            <a:pPr>
-              <a:spcAft>
-                <a:spcPts val="1200"/>
-              </a:spcAft>
-            </a:pPr>
-            <a:r>
-              <a:rPr sz="2200" b="1">
-                <a:latin typeface="Times New Roman"/>
-                <a:cs typeface="Times New Roman"/>
-              </a:rPr>
-              <a:t>54 full runs </a:t>
-            </a:r>
-            <a:r>
-              <a:rPr sz="2200">
-                <a:latin typeface="Times New Roman"/>
-                <a:cs typeface="Times New Roman"/>
-              </a:rPr>
-              <a:t>(6 machines x 3 models x 3 seeds) and 6 quick runs completed.</a:t>
-            </a:r>
-          </a:p>
-          <a:p>
-            <a:pPr>
-              <a:spcAft>
-                <a:spcPts val="1200"/>
-              </a:spcAft>
-            </a:pPr>
-            <a:r>
-              <a:rPr sz="2200" b="1">
-                <a:latin typeface="Times New Roman"/>
-                <a:cs typeface="Times New Roman"/>
-              </a:rPr>
-              <a:t>22+ automated tests </a:t>
-            </a:r>
-            <a:r>
-              <a:rPr sz="2200">
-                <a:latin typeface="Times New Roman"/>
-                <a:cs typeface="Times New Roman"/>
-              </a:rPr>
-              <a:t>cover metrics, thresholds, windows and normalisation.</a:t>
-            </a:r>
-          </a:p>
-        </p:txBody>
-      </p:sp>
-      <p:sp>
-        <p:nvSpPr>
-          <p:cNvPr id="4" name="Rounded Rectangle 3"/>
-          <p:cNvSpPr/>
-          <p:nvPr/>
-        </p:nvSpPr>
-        <p:spPr>
-          <a:xfrm>
-            <a:off x="438912" y="4617720"/>
-            <a:ext cx="11247120" cy="1280160"/>
-          </a:xfrm>
-          <a:prstGeom prst="roundRect">
-            <a:avLst>
-              <a:gd name="adj" fmla="val 8000"/>
-            </a:avLst>
-          </a:prstGeom>
-          <a:solidFill>
-            <a:srgbClr val="FBEBE7"/>
-          </a:solidFill>
-          <a:ln>
-            <a:noFill/>
-          </a:ln>
-          <a:effectLst/>
-        </p:spPr>
-        <p:style>
-          <a:lnRef idx="1">
-            <a:schemeClr val="accent1"/>
-          </a:lnRef>
-          <a:fillRef idx="3">
-            <a:schemeClr val="accent1"/>
-          </a:fillRef>
-          <a:effectRef idx="2">
-            <a:schemeClr val="accent1"/>
-          </a:effectRef>
-          <a:fontRef idx="minor">
-            <a:schemeClr val="lt1"/>
-          </a:fontRef>
-        </p:style>
-        <p:txBody>
-          <a:bodyPr rtlCol="0" anchor="ctr" wrap="square" lIns="109728" rIns="109728" tIns="54864" bIns="54864"/>
-          <a:lstStyle/>
-          <a:p>
-            <a:pPr algn="l"/>
-            <a:r>
-              <a:rPr sz="1600" b="1">
-                <a:solidFill>
-                  <a:srgbClr val="000000"/>
-                </a:solidFill>
-                <a:latin typeface="Times New Roman"/>
-                <a:cs typeface="Times New Roman"/>
-              </a:rPr>
-              <a:t>Run it</a:t>
-            </a:r>
-          </a:p>
-          <a:p>
-            <a:pPr algn="l"/>
-            <a:r>
-              <a:rPr sz="1700" b="0">
-                <a:solidFill>
-                  <a:srgbClr val="000000"/>
-                </a:solidFill>
-                <a:latin typeface="Times New Roman"/>
-                <a:cs typeface="Times New Roman"/>
-              </a:rPr>
-              <a:t>docker compose run --rm data     |     quick     |     smd     |     compare</a:t>
-            </a:r>
-          </a:p>
-        </p:txBody>
-      </p:sp>
-    </p:spTree>
-  </p:cSld>
-  <p:clrMapOvr>
-    <a:masterClrMapping/>
-  </p:clrMapOvr>
-</p:sld>
-</file>
-
-<file path=ppt/slides/slide21.xml><?xml version="1.0" encoding="utf-8"?>
 <p:sld xmlns:a="http://schemas.openxmlformats.org/drawingml/2006/main" xmlns:p="http://schemas.openxmlformats.org/presentationml/2006/main" xmlns:r="http://schemas.openxmlformats.org/officeDocument/2006/relationships">
   <p:cSld>
     <p:spTree>
@@ -9151,7 +9096,7 @@
 </p:sld>
 </file>
 
-<file path=ppt/slides/slide22.xml><?xml version="1.0" encoding="utf-8"?>
+<file path=ppt/slides/slide21.xml><?xml version="1.0" encoding="utf-8"?>
 <p:sld xmlns:a="http://schemas.openxmlformats.org/drawingml/2006/main" xmlns:p="http://schemas.openxmlformats.org/presentationml/2006/main" xmlns:r="http://schemas.openxmlformats.org/officeDocument/2006/relationships">
   <p:cSld>
     <p:spTree>
@@ -9430,7 +9375,7 @@
 </p:sld>
 </file>
 
-<file path=ppt/slides/slide23.xml><?xml version="1.0" encoding="utf-8"?>
+<file path=ppt/slides/slide22.xml><?xml version="1.0" encoding="utf-8"?>
 <p:sld xmlns:a="http://schemas.openxmlformats.org/drawingml/2006/main" xmlns:p="http://schemas.openxmlformats.org/presentationml/2006/main" xmlns:r="http://schemas.openxmlformats.org/officeDocument/2006/relationships">
   <p:cSld>
     <p:spTree>
@@ -9586,7 +9531,7 @@
 </p:sld>
 </file>
 
-<file path=ppt/slides/slide24.xml><?xml version="1.0" encoding="utf-8"?>
+<file path=ppt/slides/slide23.xml><?xml version="1.0" encoding="utf-8"?>
 <p:sld xmlns:a="http://schemas.openxmlformats.org/drawingml/2006/main" xmlns:p="http://schemas.openxmlformats.org/presentationml/2006/main" xmlns:r="http://schemas.openxmlformats.org/officeDocument/2006/relationships">
   <p:cSld>
     <p:spTree>
@@ -9755,7 +9700,7 @@
 </p:sld>
 </file>
 
-<file path=ppt/slides/slide25.xml><?xml version="1.0" encoding="utf-8"?>
+<file path=ppt/slides/slide24.xml><?xml version="1.0" encoding="utf-8"?>
 <p:sld xmlns:a="http://schemas.openxmlformats.org/drawingml/2006/main" xmlns:p="http://schemas.openxmlformats.org/presentationml/2006/main" xmlns:r="http://schemas.openxmlformats.org/officeDocument/2006/relationships">
   <p:cSld>
     <p:spTree>
@@ -9827,7 +9772,7 @@
                 <a:latin typeface="Times New Roman"/>
                 <a:cs typeface="Times New Roman"/>
               </a:rPr>
-              <a:t>github.com/PuravPatil/test-time-adaptation-tsad</a:t>
+              <a:t>github.com/PuravPatil/test-time-adaptation-tsad1</a:t>
             </a:r>
           </a:p>
           <a:p>
@@ -9924,7 +9869,7 @@
 </p:sld>
 </file>
 
-<file path=ppt/slides/slide26.xml><?xml version="1.0" encoding="utf-8"?>
+<file path=ppt/slides/slide25.xml><?xml version="1.0" encoding="utf-8"?>
 <p:sld xmlns:a="http://schemas.openxmlformats.org/drawingml/2006/main" xmlns:p="http://schemas.openxmlformats.org/presentationml/2006/main" xmlns:r="http://schemas.openxmlformats.org/officeDocument/2006/relationships">
   <p:cSld>
     <p:spTree>
@@ -10413,7 +10358,7 @@
 </p:sld>
 </file>
 
-<file path=ppt/slides/slide27.xml><?xml version="1.0" encoding="utf-8"?>
+<file path=ppt/slides/slide26.xml><?xml version="1.0" encoding="utf-8"?>
 <p:sld xmlns:a="http://schemas.openxmlformats.org/drawingml/2006/main" xmlns:p="http://schemas.openxmlformats.org/presentationml/2006/main" xmlns:r="http://schemas.openxmlformats.org/officeDocument/2006/relationships">
   <p:cSld>
     <p:spTree>
@@ -10600,6 +10545,61 @@
   <p:clrMapOvr>
     <a:masterClrMapping/>
   </p:clrMapOvr>
+</p:sld>
+</file>
+
+<file path=ppt/slides/slide27.xml><?xml version="1.0" encoding="utf-8"?>
+<p:sld xmlns:a="http://schemas.openxmlformats.org/drawingml/2006/main" xmlns:r="http://schemas.openxmlformats.org/officeDocument/2006/relationships" xmlns:p="http://schemas.openxmlformats.org/presentationml/2006/main">
+  <p:cSld>
+    <p:spTree>
+      <p:nvGrpSpPr>
+        <p:cNvPr id="1" name=""/>
+        <p:cNvGrpSpPr/>
+        <p:nvPr/>
+      </p:nvGrpSpPr>
+      <p:grpSpPr>
+        <a:xfrm>
+          <a:off x="0" y="0"/>
+          <a:ext cx="0" cy="0"/>
+          <a:chOff x="0" y="0"/>
+          <a:chExt cx="0" cy="0"/>
+        </a:xfrm>
+      </p:grpSpPr>
+      <p:sp>
+        <p:nvSpPr>
+          <p:cNvPr id="170" name="Title 3"/>
+          <p:cNvSpPr txBox="1">
+            <a:spLocks noGrp="1"/>
+          </p:cNvSpPr>
+          <p:nvPr>
+            <p:ph type="title"/>
+          </p:nvPr>
+        </p:nvSpPr>
+        <p:spPr>
+          <a:xfrm>
+            <a:off x="838200" y="2263373"/>
+            <a:ext cx="10515600" cy="1325564"/>
+          </a:xfrm>
+          <a:prstGeom prst="rect">
+            <a:avLst/>
+          </a:prstGeom>
+        </p:spPr>
+        <p:txBody>
+          <a:bodyPr/>
+          <a:lstStyle/>
+          <a:p>
+            <a:r>
+              <a:t>Thank you</a:t>
+            </a:r>
+          </a:p>
+        </p:txBody>
+      </p:sp>
+    </p:spTree>
+  </p:cSld>
+  <p:clrMapOvr>
+    <a:masterClrMapping/>
+  </p:clrMapOvr>
+  <p:transition spd="med"/>
 </p:sld>
 </file>
 

</xml_diff>